<commit_message>
Small changes to notebook to tidy
</commit_message>
<xml_diff>
--- a/assessment/presentation/From Launch to Litter Orbital Overload.pptx
+++ b/assessment/presentation/From Launch to Litter Orbital Overload.pptx
@@ -166,7 +166,7 @@
         <p:txBody>
           <a:bodyPr/>
           <a:p>
-            <a:fld id="{80E77A3C-CDF8-464D-A6C7-AD1B6319927B}" type="slidenum">
+            <a:fld id="{BCA267AE-E5A3-4F2B-919B-273D8FEFFDB2}" type="slidenum">
               <a:t>&lt;#&gt;</a:t>
             </a:fld>
           </a:p>
@@ -249,7 +249,7 @@
         <p:txBody>
           <a:bodyPr/>
           <a:p>
-            <a:fld id="{2D9855C2-0747-46EB-88C0-93083174CA53}" type="slidenum">
+            <a:fld id="{F72AE252-42CC-4696-A42D-9704070ECFC8}" type="slidenum">
               <a:t>&lt;#&gt;</a:t>
             </a:fld>
           </a:p>
@@ -332,7 +332,7 @@
         <p:txBody>
           <a:bodyPr/>
           <a:p>
-            <a:fld id="{9793766F-A097-4D00-B967-8099654B0702}" type="slidenum">
+            <a:fld id="{2B068492-FF6A-410F-A7D6-64FBDFE93790}" type="slidenum">
               <a:t>&lt;#&gt;</a:t>
             </a:fld>
           </a:p>
@@ -415,7 +415,7 @@
         <p:txBody>
           <a:bodyPr/>
           <a:p>
-            <a:fld id="{0CB3A1CD-1F24-4260-A08B-207680AE39DD}" type="slidenum">
+            <a:fld id="{024E5109-4A08-4923-938C-F17FA25AE9EE}" type="slidenum">
               <a:t>&lt;#&gt;</a:t>
             </a:fld>
           </a:p>
@@ -498,7 +498,7 @@
         <p:txBody>
           <a:bodyPr/>
           <a:p>
-            <a:fld id="{96573F55-91C6-4EFB-BACA-EAD6DAE835CC}" type="slidenum">
+            <a:fld id="{A30A0DEC-E8EC-4C81-BCDB-16686FC212D8}" type="slidenum">
               <a:t>&lt;#&gt;</a:t>
             </a:fld>
           </a:p>
@@ -664,7 +664,7 @@
         <p:txBody>
           <a:bodyPr/>
           <a:p>
-            <a:fld id="{6E559702-CD2B-430B-AF02-5ADF1C6CBB74}" type="slidenum">
+            <a:fld id="{39441D2B-C001-4ED0-975B-15C20562FE46}" type="slidenum">
               <a:t>&lt;#&gt;</a:t>
             </a:fld>
           </a:p>
@@ -747,7 +747,7 @@
         <p:txBody>
           <a:bodyPr/>
           <a:p>
-            <a:fld id="{9B69D170-6956-4A65-A6E6-4F7798BC58A5}" type="slidenum">
+            <a:fld id="{5CC43A37-ABA6-4BEF-86A9-8F4E67DF8EE3}" type="slidenum">
               <a:t>&lt;#&gt;</a:t>
             </a:fld>
           </a:p>
@@ -956,7 +956,7 @@
         <p:txBody>
           <a:bodyPr/>
           <a:p>
-            <a:fld id="{AB2B5E0B-3778-4AE6-9DA0-7A2190E0A81F}" type="slidenum">
+            <a:fld id="{3C14854A-2B45-4F07-9DCE-929A3D6FFD5C}" type="slidenum">
               <a:t>&lt;#&gt;</a:t>
             </a:fld>
           </a:p>
@@ -1039,7 +1039,7 @@
         <p:txBody>
           <a:bodyPr/>
           <a:p>
-            <a:fld id="{AEA5CD6C-FAA3-41DC-91F2-3A4E1C456C9C}" type="slidenum">
+            <a:fld id="{C4BDF325-5E79-4BC9-B219-D44F946A8834}" type="slidenum">
               <a:t>&lt;#&gt;</a:t>
             </a:fld>
           </a:p>
@@ -1162,7 +1162,7 @@
         <p:txBody>
           <a:bodyPr/>
           <a:p>
-            <a:fld id="{D48C285D-EECF-4338-981E-1E1DE1A91F2E}" type="slidenum">
+            <a:fld id="{2E68A4FB-89EB-46DC-B858-CA38E59CE082}" type="slidenum">
               <a:t>&lt;#&gt;</a:t>
             </a:fld>
           </a:p>
@@ -1245,7 +1245,7 @@
         <p:txBody>
           <a:bodyPr/>
           <a:p>
-            <a:fld id="{CC39A42D-D1FF-401A-B79D-520979DD44C6}" type="slidenum">
+            <a:fld id="{39EF1F5D-155E-48B4-8C60-7A0338674FB1}" type="slidenum">
               <a:t>&lt;#&gt;</a:t>
             </a:fld>
           </a:p>
@@ -1342,25 +1342,7 @@
                 </a:solidFill>
                 <a:latin typeface="Calibri"/>
               </a:rPr>
-              <a:t>Click to edit </a:t>
-            </a:r>
-            <a:r>
-              <a:rPr b="0" lang="en-US" sz="4400" spc="-1" strike="noStrike">
-                <a:solidFill>
-                  <a:schemeClr val="dk1"/>
-                </a:solidFill>
-                <a:latin typeface="Calibri"/>
-              </a:rPr>
-              <a:t>Master title </a:t>
-            </a:r>
-            <a:r>
-              <a:rPr b="0" lang="en-US" sz="4400" spc="-1" strike="noStrike">
-                <a:solidFill>
-                  <a:schemeClr val="dk1"/>
-                </a:solidFill>
-                <a:latin typeface="Calibri"/>
-              </a:rPr>
-              <a:t>style</a:t>
+              <a:t>Click to edit Master title style</a:t>
             </a:r>
             <a:endParaRPr b="0" lang="en-US" sz="4400" spc="-1" strike="noStrike">
               <a:solidFill>
@@ -1551,7 +1533,7 @@
               </a:lnSpc>
               <a:buNone/>
             </a:pPr>
-            <a:fld id="{59850786-4A77-474B-B571-97A85FF242C2}" type="slidenum">
+            <a:fld id="{42F2DF88-9B2C-4455-9911-78685108DEE6}" type="slidenum">
               <a:rPr b="0" lang="en-US" sz="1200" spc="-1" strike="noStrike">
                 <a:solidFill>
                   <a:schemeClr val="dk1">
@@ -2073,7 +2055,7 @@
               </a:lnSpc>
               <a:buNone/>
             </a:pPr>
-            <a:fld id="{4AA0028F-63F2-407A-B931-EFA047A39C12}" type="slidenum">
+            <a:fld id="{45A54B93-CEC8-4400-94B9-7C13CB892651}" type="slidenum">
               <a:rPr b="0" lang="en-US" sz="1200" spc="-1" strike="noStrike">
                 <a:solidFill>
                   <a:schemeClr val="dk1">
@@ -2641,7 +2623,7 @@
               </a:lnSpc>
               <a:buNone/>
             </a:pPr>
-            <a:fld id="{9B963DD3-22B9-498E-BFE0-C950AB4AB7D8}" type="slidenum">
+            <a:fld id="{19B4D6BF-8E15-486A-B68F-4A4A718FE345}" type="slidenum">
               <a:rPr b="0" lang="en-US" sz="1200" spc="-1" strike="noStrike">
                 <a:solidFill>
                   <a:schemeClr val="dk1">
@@ -2735,7 +2717,25 @@
                 </a:solidFill>
                 <a:latin typeface="Calibri"/>
               </a:rPr>
-              <a:t>Click to edit Master title style</a:t>
+              <a:t>Click to edit </a:t>
+            </a:r>
+            <a:r>
+              <a:rPr b="0" lang="en-US" sz="4400" spc="-1" strike="noStrike">
+                <a:solidFill>
+                  <a:schemeClr val="dk1"/>
+                </a:solidFill>
+                <a:latin typeface="Calibri"/>
+              </a:rPr>
+              <a:t>Master title </a:t>
+            </a:r>
+            <a:r>
+              <a:rPr b="0" lang="en-US" sz="4400" spc="-1" strike="noStrike">
+                <a:solidFill>
+                  <a:schemeClr val="dk1"/>
+                </a:solidFill>
+                <a:latin typeface="Calibri"/>
+              </a:rPr>
+              <a:t>style</a:t>
             </a:r>
             <a:endParaRPr b="0" lang="en-US" sz="4400" spc="-1" strike="noStrike">
               <a:solidFill>
@@ -3105,7 +3105,7 @@
               </a:lnSpc>
               <a:buNone/>
             </a:pPr>
-            <a:fld id="{6D9C3322-2CA0-4844-9E4F-68108CEC0CDA}" type="slidenum">
+            <a:fld id="{F7B54AD1-4B96-499F-B4EC-D114FFEDD387}" type="slidenum">
               <a:rPr b="0" lang="en-US" sz="1200" spc="-1" strike="noStrike">
                 <a:solidFill>
                   <a:schemeClr val="dk1">
@@ -3569,7 +3569,7 @@
               </a:lnSpc>
               <a:buNone/>
             </a:pPr>
-            <a:fld id="{7E793BBA-8702-4318-BD16-9C5720236316}" type="slidenum">
+            <a:fld id="{5B836522-343A-44BA-822A-A67E74FCBC70}" type="slidenum">
               <a:rPr b="0" lang="en-US" sz="1200" spc="-1" strike="noStrike">
                 <a:solidFill>
                   <a:schemeClr val="dk1">
@@ -3663,25 +3663,7 @@
                 </a:solidFill>
                 <a:latin typeface="Calibri"/>
               </a:rPr>
-              <a:t>Click to edit </a:t>
-            </a:r>
-            <a:r>
-              <a:rPr b="0" lang="en-US" sz="4400" spc="-1" strike="noStrike">
-                <a:solidFill>
-                  <a:schemeClr val="dk1"/>
-                </a:solidFill>
-                <a:latin typeface="Calibri"/>
-              </a:rPr>
-              <a:t>Master title </a:t>
-            </a:r>
-            <a:r>
-              <a:rPr b="0" lang="en-US" sz="4400" spc="-1" strike="noStrike">
-                <a:solidFill>
-                  <a:schemeClr val="dk1"/>
-                </a:solidFill>
-                <a:latin typeface="Calibri"/>
-              </a:rPr>
-              <a:t>style</a:t>
+              <a:t>Click to edit Master title style</a:t>
             </a:r>
             <a:endParaRPr b="0" lang="en-US" sz="4400" spc="-1" strike="noStrike">
               <a:solidFill>
@@ -4051,7 +4033,7 @@
               </a:lnSpc>
               <a:buNone/>
             </a:pPr>
-            <a:fld id="{BDCD5C00-5FCA-4C55-B098-1F29FCEE6946}" type="slidenum">
+            <a:fld id="{1127B1A8-EEF2-4ECB-AA95-43EF66F929B7}" type="slidenum">
               <a:rPr b="0" lang="en-US" sz="1200" spc="-1" strike="noStrike">
                 <a:solidFill>
                   <a:schemeClr val="dk1">
@@ -4396,7 +4378,7 @@
               </a:lnSpc>
               <a:buNone/>
             </a:pPr>
-            <a:fld id="{1C8634B3-F578-4D82-97B9-EAFEED8C697F}" type="slidenum">
+            <a:fld id="{D7373975-94C2-4FF6-BE59-EC1A1341FC18}" type="slidenum">
               <a:rPr b="0" lang="en-US" sz="1200" spc="-1" strike="noStrike">
                 <a:solidFill>
                   <a:schemeClr val="dk1">
@@ -5039,7 +5021,7 @@
               </a:lnSpc>
               <a:buNone/>
             </a:pPr>
-            <a:fld id="{21C09D2F-E3E2-42DE-AAF3-E4FCCF64C4E8}" type="slidenum">
+            <a:fld id="{B3A0E49E-FE22-4EC3-9771-DE197B3C40FD}" type="slidenum">
               <a:rPr b="0" lang="en-US" sz="1200" spc="-1" strike="noStrike">
                 <a:solidFill>
                   <a:schemeClr val="dk1">
@@ -5798,7 +5780,7 @@
               </a:lnSpc>
               <a:buNone/>
             </a:pPr>
-            <a:fld id="{5664A273-42E8-41A7-9483-CAF5E2A88BE9}" type="slidenum">
+            <a:fld id="{DA8F9B95-4131-4A1F-B402-776F670E0E01}" type="slidenum">
               <a:rPr b="0" lang="en-US" sz="1200" spc="-1" strike="noStrike">
                 <a:solidFill>
                   <a:schemeClr val="dk1">
@@ -6083,7 +6065,7 @@
               </a:lnSpc>
               <a:buNone/>
             </a:pPr>
-            <a:fld id="{36D84F01-6ACF-451B-BEAE-BD88F8BADA36}" type="slidenum">
+            <a:fld id="{A8CBC18F-4C6D-426B-B530-B54BA1529172}" type="slidenum">
               <a:rPr b="0" lang="en-US" sz="1200" spc="-1" strike="noStrike">
                 <a:solidFill>
                   <a:schemeClr val="dk1">
@@ -6316,7 +6298,7 @@
               </a:lnSpc>
               <a:buNone/>
             </a:pPr>
-            <a:fld id="{718104BA-566A-4E61-A031-54C6124F1396}" type="slidenum">
+            <a:fld id="{4B52C89D-D271-4194-B92C-A9777EF9608B}" type="slidenum">
               <a:rPr b="0" lang="en-US" sz="1200" spc="-1" strike="noStrike">
                 <a:solidFill>
                   <a:schemeClr val="dk1">
@@ -13054,7 +13036,7 @@
         </p:blipFill>
         <p:spPr>
           <a:xfrm>
-            <a:off x="2514600" y="2391120"/>
+            <a:off x="334080" y="2366280"/>
             <a:ext cx="13182120" cy="7689240"/>
           </a:xfrm>
           <a:prstGeom prst="rect">

</xml_diff>